<commit_message>
v2 pitch-grade: 4 image variants, one-pager PDF, media FAQ, press kit, Bahnschrift typography upgrade
Visual system v2:
- Hero / Twitter / Square / Vertical PNG variants (Quiet Substrate)
- Bahnschrift (DIN-class) typography replacing Arial across all designed assets
- Sharper composition, dedicated spec-sheet meta layer, refined glow + lattice

New operational docs:
- 16-media-faq.md (15 anticipated journalist Q&As + bridge phrases)
- 17-press-kit-boilerplate.md (boilerplate, bios, factbox, quotables, contacts)
- astarter-one-pager.pdf (A4 single-page executive fact sheet, ReportLab)

Refreshed:
- PPTX deck with Bahnschrift typography
- README with full distribution map
</commit_message>
<xml_diff>
--- a/astarter-cointime-2026-05-24/astarter-pitch-deck.pptx
+++ b/astarter-cointime-2026-05-24/astarter-pitch-deck.pptx
@@ -3297,7 +3297,7 @@
                 <a:solidFill>
                   <a:srgbClr val="FFFFFF"/>
                 </a:solidFill>
-                <a:latin typeface="Calibri"/>
+                <a:latin typeface="Bahnschrift"/>
               </a:rPr>
               <a:t>MEDIA</a:t>
             </a:r>
@@ -3313,7 +3313,7 @@
                 <a:solidFill>
                   <a:srgbClr val="FFFFFF"/>
                 </a:solidFill>
-                <a:latin typeface="Calibri"/>
+                <a:latin typeface="Bahnschrift"/>
               </a:rPr>
               <a:t>PACKAGE</a:t>
             </a:r>
@@ -3352,7 +3352,7 @@
                 <a:solidFill>
                   <a:srgbClr val="D4C8FF"/>
                 </a:solidFill>
-                <a:latin typeface="Calibri"/>
+                <a:latin typeface="Bahnschrift"/>
               </a:rPr>
               <a:t>Settlement infrastructure for the autonomous AI Agent economy.</a:t>
             </a:r>
@@ -3430,7 +3430,7 @@
                 <a:solidFill>
                   <a:srgbClr val="FFFFFF"/>
                 </a:solidFill>
-                <a:latin typeface="Calibri"/>
+                <a:latin typeface="Bahnschrift"/>
               </a:rPr>
               <a:t>QUIET</a:t>
             </a:r>
@@ -3446,7 +3446,7 @@
                 <a:solidFill>
                   <a:srgbClr val="FFFFFF"/>
                 </a:solidFill>
-                <a:latin typeface="Calibri"/>
+                <a:latin typeface="Bahnschrift"/>
               </a:rPr>
               <a:t>SUBSTRATE</a:t>
             </a:r>
@@ -3585,7 +3585,7 @@
                 <a:solidFill>
                   <a:srgbClr val="FFFFFF"/>
                 </a:solidFill>
-                <a:latin typeface="Calibri"/>
+                <a:latin typeface="Bahnschrift"/>
               </a:rPr>
               <a:t>Open items before send.</a:t>
             </a:r>
@@ -3663,7 +3663,7 @@
                 <a:solidFill>
                   <a:srgbClr val="FFFFFF"/>
                 </a:solidFill>
-                <a:latin typeface="Calibri"/>
+                <a:latin typeface="Bahnschrift"/>
               </a:rPr>
               <a:t>Share TGE date / listing venues in copy?</a:t>
             </a:r>
@@ -3741,7 +3741,7 @@
                 <a:solidFill>
                   <a:srgbClr val="FFFFFF"/>
                 </a:solidFill>
-                <a:latin typeface="Calibri"/>
+                <a:latin typeface="Bahnschrift"/>
               </a:rPr>
               <a:t>Confirmed second chain we can name?</a:t>
             </a:r>
@@ -3819,7 +3819,7 @@
                 <a:solidFill>
                   <a:srgbClr val="FFFFFF"/>
                 </a:solidFill>
-                <a:latin typeface="Calibri"/>
+                <a:latin typeface="Bahnschrift"/>
               </a:rPr>
               <a:t>CEO quote on the DeFAI thesis?</a:t>
             </a:r>
@@ -3897,7 +3897,7 @@
                 <a:solidFill>
                   <a:srgbClr val="FFFFFF"/>
                 </a:solidFill>
-                <a:latin typeface="Calibri"/>
+                <a:latin typeface="Bahnschrift"/>
               </a:rPr>
               <a:t>Hold for a second partnership announcement?</a:t>
             </a:r>
@@ -3975,7 +3975,7 @@
                 <a:solidFill>
                   <a:srgbClr val="FFFFFF"/>
                 </a:solidFill>
-                <a:latin typeface="Calibri"/>
+                <a:latin typeface="Bahnschrift"/>
               </a:rPr>
               <a:t>Approve syndication beyond Cointime  (PANews / BlockBeats / TechFlow)?</a:t>
             </a:r>
@@ -4231,7 +4231,7 @@
                 <a:solidFill>
                   <a:srgbClr val="FFFFFF"/>
                 </a:solidFill>
-                <a:latin typeface="Calibri"/>
+                <a:latin typeface="Bahnschrift"/>
               </a:rPr>
               <a:t>DeFi's next bottleneck</a:t>
             </a:r>
@@ -4247,7 +4247,7 @@
                 <a:solidFill>
                   <a:srgbClr val="FFFFFF"/>
                 </a:solidFill>
-                <a:latin typeface="Calibri"/>
+                <a:latin typeface="Bahnschrift"/>
               </a:rPr>
               <a:t>isn't liquidity —</a:t>
             </a:r>
@@ -4263,7 +4263,7 @@
                 <a:solidFill>
                   <a:srgbClr val="FFFFFF"/>
                 </a:solidFill>
-                <a:latin typeface="Calibri"/>
+                <a:latin typeface="Bahnschrift"/>
               </a:rPr>
               <a:t>it's settlement.</a:t>
             </a:r>
@@ -4302,7 +4302,7 @@
                 <a:solidFill>
                   <a:srgbClr val="D4C8FF"/>
                 </a:solidFill>
-                <a:latin typeface="Calibri"/>
+                <a:latin typeface="Bahnschrift"/>
               </a:rPr>
               <a:t>The defining trade of the 2026 cycle is no longer about which chain</a:t>
             </a:r>
@@ -4318,7 +4318,7 @@
                 <a:solidFill>
                   <a:srgbClr val="D4C8FF"/>
                 </a:solidFill>
-                <a:latin typeface="Calibri"/>
+                <a:latin typeface="Bahnschrift"/>
               </a:rPr>
               <a:t>wins liquidity. It is about who builds the settlement substrate for</a:t>
             </a:r>
@@ -4334,7 +4334,7 @@
                 <a:solidFill>
                   <a:srgbClr val="D4C8FF"/>
                 </a:solidFill>
-                <a:latin typeface="Calibri"/>
+                <a:latin typeface="Bahnschrift"/>
               </a:rPr>
               <a:t>the first generation of economic actors that are not human.</a:t>
             </a:r>
@@ -4551,7 +4551,7 @@
                 <a:solidFill>
                   <a:srgbClr val="FFFFFF"/>
                 </a:solidFill>
-                <a:latin typeface="Calibri"/>
+                <a:latin typeface="Bahnschrift"/>
               </a:rPr>
               <a:t>AI Agents have crossed the line</a:t>
             </a:r>
@@ -4567,7 +4567,7 @@
                 <a:solidFill>
                   <a:srgbClr val="FFFFFF"/>
                 </a:solidFill>
-                <a:latin typeface="Calibri"/>
+                <a:latin typeface="Bahnschrift"/>
               </a:rPr>
               <a:t>from narrative into deployment.</a:t>
             </a:r>
@@ -4688,7 +4688,7 @@
                 <a:solidFill>
                   <a:srgbClr val="FFFFFF"/>
                 </a:solidFill>
-                <a:latin typeface="Calibri"/>
+                <a:latin typeface="Bahnschrift"/>
               </a:rPr>
               <a:t>376%</a:t>
             </a:r>
@@ -4727,7 +4727,7 @@
                 <a:solidFill>
                   <a:srgbClr val="D4C8FF"/>
                 </a:solidFill>
-                <a:latin typeface="Calibri"/>
+                <a:latin typeface="Bahnschrift"/>
               </a:rPr>
               <a:t>Agent-driven returns on Polymarket vs. &lt;13% for human wallets</a:t>
             </a:r>
@@ -4848,7 +4848,7 @@
                 <a:solidFill>
                   <a:srgbClr val="FFFFFF"/>
                 </a:solidFill>
-                <a:latin typeface="Calibri"/>
+                <a:latin typeface="Bahnschrift"/>
               </a:rPr>
               <a:t>$2B+</a:t>
             </a:r>
@@ -4887,7 +4887,7 @@
                 <a:solidFill>
                   <a:srgbClr val="D4C8FF"/>
                 </a:solidFill>
-                <a:latin typeface="Calibri"/>
+                <a:latin typeface="Bahnschrift"/>
               </a:rPr>
               <a:t>Cumulative agent-linked trading volume</a:t>
             </a:r>
@@ -5008,7 +5008,7 @@
                 <a:solidFill>
                   <a:srgbClr val="FFFFFF"/>
                 </a:solidFill>
-                <a:latin typeface="Calibri"/>
+                <a:latin typeface="Bahnschrift"/>
               </a:rPr>
               <a:t>150K+</a:t>
             </a:r>
@@ -5047,7 +5047,7 @@
                 <a:solidFill>
                   <a:srgbClr val="D4C8FF"/>
                 </a:solidFill>
-                <a:latin typeface="Calibri"/>
+                <a:latin typeface="Bahnschrift"/>
               </a:rPr>
               <a:t>Deployed agents on the ASI:One framework</a:t>
             </a:r>
@@ -5264,7 +5264,7 @@
                 <a:solidFill>
                   <a:srgbClr val="FFFFFF"/>
                 </a:solidFill>
-                <a:latin typeface="Calibri"/>
+                <a:latin typeface="Bahnschrift"/>
               </a:rPr>
               <a:t>Agents don't need better models.</a:t>
             </a:r>
@@ -5280,7 +5280,7 @@
                 <a:solidFill>
                   <a:srgbClr val="FFFFFF"/>
                 </a:solidFill>
-                <a:latin typeface="Calibri"/>
+                <a:latin typeface="Bahnschrift"/>
               </a:rPr>
               <a:t>They need better rails.</a:t>
             </a:r>
@@ -5319,7 +5319,7 @@
                 <a:solidFill>
                   <a:srgbClr val="D4C8FF"/>
                 </a:solidFill>
-                <a:latin typeface="Calibri"/>
+                <a:latin typeface="Bahnschrift"/>
               </a:rPr>
               <a:t>Existing DeFi was built for human counterparties. Slippage, MEV,</a:t>
             </a:r>
@@ -5335,7 +5335,7 @@
                 <a:solidFill>
                   <a:srgbClr val="D4C8FF"/>
                 </a:solidFill>
-                <a:latin typeface="Calibri"/>
+                <a:latin typeface="Bahnschrift"/>
               </a:rPr>
               <a:t>gas, disputes — every primitive assumes a person can intervene.</a:t>
             </a:r>
@@ -5351,7 +5351,7 @@
                 <a:solidFill>
                   <a:srgbClr val="D4C8FF"/>
                 </a:solidFill>
-                <a:latin typeface="Calibri"/>
+                <a:latin typeface="Bahnschrift"/>
               </a:rPr>
               <a:t>Agents can't improvise. They require deterministic settlement.</a:t>
             </a:r>
@@ -5568,7 +5568,7 @@
                 <a:solidFill>
                   <a:srgbClr val="00E5FF"/>
                 </a:solidFill>
-                <a:latin typeface="Calibri"/>
+                <a:latin typeface="Bahnschrift"/>
               </a:rPr>
               <a:t>DeFAI</a:t>
             </a:r>
@@ -5607,7 +5607,7 @@
                 <a:solidFill>
                   <a:srgbClr val="FFFFFF"/>
                 </a:solidFill>
-                <a:latin typeface="Calibri"/>
+                <a:latin typeface="Bahnschrift"/>
               </a:rPr>
               <a:t>Decentralized finance for autonomous AI execution.</a:t>
             </a:r>
@@ -5646,7 +5646,7 @@
                 <a:solidFill>
                   <a:srgbClr val="D4C8FF"/>
                 </a:solidFill>
-                <a:latin typeface="Calibri"/>
+                <a:latin typeface="Bahnschrift"/>
               </a:rPr>
               <a:t>The teams credibly inside this category — Astarter, Olas, Giza,</a:t>
             </a:r>
@@ -5662,7 +5662,7 @@
                 <a:solidFill>
                   <a:srgbClr val="D4C8FF"/>
                 </a:solidFill>
-                <a:latin typeface="Calibri"/>
+                <a:latin typeface="Bahnschrift"/>
               </a:rPr>
               <a:t>the Fetch.ai/ASI alliance — have each chosen a different point</a:t>
             </a:r>
@@ -5678,7 +5678,7 @@
                 <a:solidFill>
                   <a:srgbClr val="D4C8FF"/>
                 </a:solidFill>
-                <a:latin typeface="Calibri"/>
+                <a:latin typeface="Bahnschrift"/>
               </a:rPr>
               <a:t>in the stack to anchor.</a:t>
             </a:r>
@@ -5717,7 +5717,7 @@
                 <a:solidFill>
                   <a:srgbClr val="9D5CFF"/>
                 </a:solidFill>
-                <a:latin typeface="Calibri"/>
+                <a:latin typeface="Bahnschrift"/>
               </a:rPr>
               <a:t>Astarter has chosen the settlement layer itself.</a:t>
             </a:r>
@@ -5934,7 +5934,7 @@
                 <a:solidFill>
                   <a:srgbClr val="FFFFFF"/>
                 </a:solidFill>
-                <a:latin typeface="Calibri"/>
+                <a:latin typeface="Bahnschrift"/>
               </a:rPr>
               <a:t>Four production components.</a:t>
             </a:r>
@@ -5950,7 +5950,7 @@
                 <a:solidFill>
                   <a:srgbClr val="FFFFFF"/>
                 </a:solidFill>
-                <a:latin typeface="Calibri"/>
+                <a:latin typeface="Bahnschrift"/>
               </a:rPr>
               <a:t>One repositioned thesis.</a:t>
             </a:r>
@@ -6114,7 +6114,7 @@
                 <a:solidFill>
                   <a:srgbClr val="FFFFFF"/>
                 </a:solidFill>
-                <a:latin typeface="Calibri"/>
+                <a:latin typeface="Bahnschrift"/>
               </a:rPr>
               <a:t>LAUNCHPAD</a:t>
             </a:r>
@@ -6153,7 +6153,7 @@
                 <a:solidFill>
                   <a:srgbClr val="D4C8FF"/>
                 </a:solidFill>
-                <a:latin typeface="Calibri"/>
+                <a:latin typeface="Bahnschrift"/>
               </a:rPr>
               <a:t>Agent-native issuance</a:t>
             </a:r>
@@ -6317,7 +6317,7 @@
                 <a:solidFill>
                   <a:srgbClr val="FFFFFF"/>
                 </a:solidFill>
-                <a:latin typeface="Calibri"/>
+                <a:latin typeface="Bahnschrift"/>
               </a:rPr>
               <a:t>DEX</a:t>
             </a:r>
@@ -6356,7 +6356,7 @@
                 <a:solidFill>
                   <a:srgbClr val="D4C8FF"/>
                 </a:solidFill>
-                <a:latin typeface="Calibri"/>
+                <a:latin typeface="Bahnschrift"/>
               </a:rPr>
               <a:t>On-chain liquidity</a:t>
             </a:r>
@@ -6520,7 +6520,7 @@
                 <a:solidFill>
                   <a:srgbClr val="FFFFFF"/>
                 </a:solidFill>
-                <a:latin typeface="Calibri"/>
+                <a:latin typeface="Bahnschrift"/>
               </a:rPr>
               <a:t>MONEY MARKET</a:t>
             </a:r>
@@ -6559,7 +6559,7 @@
                 <a:solidFill>
                   <a:srgbClr val="D4C8FF"/>
                 </a:solidFill>
-                <a:latin typeface="Calibri"/>
+                <a:latin typeface="Bahnschrift"/>
               </a:rPr>
               <a:t>Credit primitives</a:t>
             </a:r>
@@ -6723,7 +6723,7 @@
                 <a:solidFill>
                   <a:srgbClr val="FFFFFF"/>
                 </a:solidFill>
-                <a:latin typeface="Calibri"/>
+                <a:latin typeface="Bahnschrift"/>
               </a:rPr>
               <a:t>TECH SERVICE PLATFORM</a:t>
             </a:r>
@@ -6762,7 +6762,7 @@
                 <a:solidFill>
                   <a:srgbClr val="D4C8FF"/>
                 </a:solidFill>
-                <a:latin typeface="Calibri"/>
+                <a:latin typeface="Bahnschrift"/>
               </a:rPr>
               <a:t>Builder tooling</a:t>
             </a:r>
@@ -6801,7 +6801,7 @@
                 <a:solidFill>
                   <a:srgbClr val="D4C8FF"/>
                 </a:solidFill>
-                <a:latin typeface="Calibri"/>
+                <a:latin typeface="Bahnschrift"/>
               </a:rPr>
               <a:t>Same primitives. Repointed at the layer where autonomous agents need to live.</a:t>
             </a:r>
@@ -7018,7 +7018,7 @@
                 <a:solidFill>
                   <a:srgbClr val="FFFFFF"/>
                 </a:solidFill>
-                <a:latin typeface="Calibri"/>
+                <a:latin typeface="Bahnschrift"/>
               </a:rPr>
               <a:t>Astarter  ×  UXLINK</a:t>
             </a:r>
@@ -7057,7 +7057,7 @@
                 <a:solidFill>
                   <a:srgbClr val="00E5FF"/>
                 </a:solidFill>
-                <a:latin typeface="Calibri"/>
+                <a:latin typeface="Bahnschrift"/>
               </a:rPr>
               <a:t>Execution layer  +  distribution layer.</a:t>
             </a:r>
@@ -7178,7 +7178,7 @@
                 <a:solidFill>
                   <a:srgbClr val="FFFFFF"/>
                 </a:solidFill>
-                <a:latin typeface="Calibri"/>
+                <a:latin typeface="Bahnschrift"/>
               </a:rPr>
               <a:t>Brings the execution layer:</a:t>
             </a:r>
@@ -7194,7 +7194,7 @@
                 <a:solidFill>
                   <a:srgbClr val="FFFFFF"/>
                 </a:solidFill>
-                <a:latin typeface="Calibri"/>
+                <a:latin typeface="Bahnschrift"/>
               </a:rPr>
               <a:t>the financial primitives agents</a:t>
             </a:r>
@@ -7210,7 +7210,7 @@
                 <a:solidFill>
                   <a:srgbClr val="FFFFFF"/>
                 </a:solidFill>
-                <a:latin typeface="Calibri"/>
+                <a:latin typeface="Bahnschrift"/>
               </a:rPr>
               <a:t>need to clear value on-chain.</a:t>
             </a:r>
@@ -7331,7 +7331,7 @@
                 <a:solidFill>
                   <a:srgbClr val="FFFFFF"/>
                 </a:solidFill>
-                <a:latin typeface="Calibri"/>
+                <a:latin typeface="Bahnschrift"/>
               </a:rPr>
               <a:t>Brings the distribution layer:</a:t>
             </a:r>
@@ -7347,7 +7347,7 @@
                 <a:solidFill>
                   <a:srgbClr val="FFFFFF"/>
                 </a:solidFill>
-                <a:latin typeface="Calibri"/>
+                <a:latin typeface="Bahnschrift"/>
               </a:rPr>
               <a:t>active Web3 social graph for</a:t>
             </a:r>
@@ -7363,7 +7363,7 @@
                 <a:solidFill>
                   <a:srgbClr val="FFFFFF"/>
                 </a:solidFill>
-                <a:latin typeface="Calibri"/>
+                <a:latin typeface="Bahnschrift"/>
               </a:rPr>
               <a:t>agent-native applications.</a:t>
             </a:r>
@@ -7580,7 +7580,7 @@
                 <a:solidFill>
                   <a:srgbClr val="00E5FF"/>
                 </a:solidFill>
-                <a:latin typeface="Calibri"/>
+                <a:latin typeface="Bahnschrift"/>
               </a:rPr>
               <a:t>$AA</a:t>
             </a:r>
@@ -7697,7 +7697,7 @@
                 <a:solidFill>
                   <a:srgbClr val="FFFFFF"/>
                 </a:solidFill>
-                <a:latin typeface="Calibri"/>
+                <a:latin typeface="Bahnschrift"/>
               </a:rPr>
               <a:t>Agent-to-agent settlement</a:t>
             </a:r>
@@ -7775,7 +7775,7 @@
                 <a:solidFill>
                   <a:srgbClr val="FFFFFF"/>
                 </a:solidFill>
-                <a:latin typeface="Calibri"/>
+                <a:latin typeface="Bahnschrift"/>
               </a:rPr>
               <a:t>DePIN compute resources</a:t>
             </a:r>
@@ -7853,7 +7853,7 @@
                 <a:solidFill>
                   <a:srgbClr val="FFFFFF"/>
                 </a:solidFill>
-                <a:latin typeface="Calibri"/>
+                <a:latin typeface="Bahnschrift"/>
               </a:rPr>
               <a:t>Protocol parameters</a:t>
             </a:r>
@@ -7931,7 +7931,7 @@
                 <a:solidFill>
                   <a:srgbClr val="FFFFFF"/>
                 </a:solidFill>
-                <a:latin typeface="Calibri"/>
+                <a:latin typeface="Bahnschrift"/>
               </a:rPr>
               <a:t>Money Market for agent credit</a:t>
             </a:r>
@@ -8187,7 +8187,7 @@
                 <a:solidFill>
                   <a:srgbClr val="FFFFFF"/>
                 </a:solidFill>
-                <a:latin typeface="Calibri"/>
+                <a:latin typeface="Bahnschrift"/>
               </a:rPr>
               <a:t>Three signals.</a:t>
             </a:r>
@@ -8203,7 +8203,7 @@
                 <a:solidFill>
                   <a:srgbClr val="FFFFFF"/>
                 </a:solidFill>
-                <a:latin typeface="Calibri"/>
+                <a:latin typeface="Bahnschrift"/>
               </a:rPr>
               <a:t>Next two quarters.</a:t>
             </a:r>
@@ -8242,7 +8242,7 @@
                 <a:solidFill>
                   <a:srgbClr val="00E5FF"/>
                 </a:solidFill>
-                <a:latin typeface="Calibri"/>
+                <a:latin typeface="Bahnschrift"/>
               </a:rPr>
               <a:t>01</a:t>
             </a:r>
@@ -8281,7 +8281,7 @@
                 <a:solidFill>
                   <a:srgbClr val="FFFFFF"/>
                 </a:solidFill>
-                <a:latin typeface="Calibri"/>
+                <a:latin typeface="Bahnschrift"/>
               </a:rPr>
               <a:t>AGENT-NATIVE PRODUCT RELEASE</a:t>
             </a:r>
@@ -8320,7 +8320,7 @@
                 <a:solidFill>
                   <a:srgbClr val="D4C8FF"/>
                 </a:solidFill>
-                <a:latin typeface="Calibri"/>
+                <a:latin typeface="Bahnschrift"/>
               </a:rPr>
               <a:t>DeFAI execution layer in functional beta with one external production deployment.</a:t>
             </a:r>
@@ -8359,7 +8359,7 @@
                 <a:solidFill>
                   <a:srgbClr val="00E5FF"/>
                 </a:solidFill>
-                <a:latin typeface="Calibri"/>
+                <a:latin typeface="Bahnschrift"/>
               </a:rPr>
               <a:t>02</a:t>
             </a:r>
@@ -8398,7 +8398,7 @@
                 <a:solidFill>
                   <a:srgbClr val="FFFFFF"/>
                 </a:solidFill>
-                <a:latin typeface="Calibri"/>
+                <a:latin typeface="Bahnschrift"/>
               </a:rPr>
               <a:t>MULTI-CHAIN EXPANSION</a:t>
             </a:r>
@@ -8437,7 +8437,7 @@
                 <a:solidFill>
                   <a:srgbClr val="D4C8FF"/>
                 </a:solidFill>
-                <a:latin typeface="Calibri"/>
+                <a:latin typeface="Bahnschrift"/>
               </a:rPr>
               <a:t>Confirmed deployment beyond Cardano into EVM and/or Solana environments.</a:t>
             </a:r>
@@ -8476,7 +8476,7 @@
                 <a:solidFill>
                   <a:srgbClr val="00E5FF"/>
                 </a:solidFill>
-                <a:latin typeface="Calibri"/>
+                <a:latin typeface="Bahnschrift"/>
               </a:rPr>
               <a:t>03</a:t>
             </a:r>
@@ -8515,7 +8515,7 @@
                 <a:solidFill>
                   <a:srgbClr val="FFFFFF"/>
                 </a:solidFill>
-                <a:latin typeface="Calibri"/>
+                <a:latin typeface="Bahnschrift"/>
               </a:rPr>
               <a:t>ADDITIONAL STRATEGIC ALLIANCES</a:t>
             </a:r>
@@ -8554,7 +8554,7 @@
                 <a:solidFill>
                   <a:srgbClr val="D4C8FF"/>
                 </a:solidFill>
-                <a:latin typeface="Calibri"/>
+                <a:latin typeface="Bahnschrift"/>
               </a:rPr>
               <a:t>At least one more UXLINK-caliber partnership within 90 days.</a:t>
             </a:r>

</xml_diff>